<commit_message>
Deck: the closing slide matches the rest instead of inverting
It was the one dark slide in the deck, with its own card colours, its own title
position and its own text sizes. That reads as a different document stapled on
the end rather than as the last page of this one.

It now uses the same light background, the same chip and title block at the same
height, the same concrete cards with amber small-caps headings, and the same
muted footer as every other content slide. The chip carries an arrow, in the
same amber as the four stage chips, so the close points back at the opening.

Co-Authored-By: Claude Opus 5 <noreply@anthropic.com>
Claude-Session: https://claude.ai/code/session_01XfgDuKyxR6wQVPSFhWJ62F
</commit_message>
<xml_diff>
--- a/docs/BINMAN-how-it-works.pptx
+++ b/docs/BINMAN-how-it-works.pptx
@@ -117,12 +117,12 @@
   <p:extLst>
     <p:ext uri="{521415D9-36F7-43E2-AB2F-B90AF26B5E84}">
       <p14:sectionLst xmlns:p14="http://schemas.microsoft.com/office/powerpoint/2010/main">
-        <p14:section name="Overview" id="{b6566cc2-85ed-d129-59fe-607b78b0ac49}">
+        <p14:section name="Overview" id="{db31bb5e-656e-47fd-0754-611a8ba5da01}">
           <p14:sldIdLst>
             <p14:sldId id="256"/>
           </p14:sldIdLst>
         </p14:section>
-        <p14:section name="How it is built" id="{5d7e5cc2-5c36-087a-8385-815b4b68986d}">
+        <p14:section name="How it is built" id="{315bf5c6-6243-5fa5-ea8f-0a4620407059}">
           <p14:sldIdLst>
             <p14:sldId id="257"/>
             <p14:sldId id="258"/>
@@ -130,7 +130,7 @@
             <p14:sldId id="260"/>
           </p14:sldIdLst>
         </p14:section>
-        <p14:section name="What it answers" id="{e5100555-f81b-1420-d11c-dc9ad0f5c2fb}">
+        <p14:section name="What it answers" id="{3b125dda-5813-a1c7-fb1c-01c2844280c8}">
           <p14:sldIdLst>
             <p14:sldId id="261"/>
             <p14:sldId id="262"/>
@@ -138,12 +138,12 @@
             <p14:sldId id="264"/>
           </p14:sldIdLst>
         </p14:section>
-        <p14:section name="What did not work" id="{03bd60a8-c2e3-a0b1-b777-41ae8790be84}">
+        <p14:section name="What did not work" id="{1593e732-939c-57c3-76e1-d7438e5ef604}">
           <p14:sldIdLst>
             <p14:sldId id="265"/>
           </p14:sldIdLst>
         </p14:section>
-        <p14:section name="Working together" id="{11135443-4f2b-a12a-7538-71cfc0da2224}">
+        <p14:section name="Working together" id="{57361fd7-a805-a521-2049-fb6a87c8e7f7}">
           <p14:sldIdLst>
             <p14:sldId id="266"/>
           </p14:sldIdLst>
@@ -3106,14 +3106,41 @@
       </p:grpSpPr>
       <p:sp>
         <p:nvSpPr>
-          <p:cNvPr id="2" name="Text 0"/>
-          <p:cNvSpPr txBox="1"/>
-          <p:nvPr/>
-        </p:nvSpPr>
-        <p:spPr>
-          <a:xfrm>
-            <a:off x="502920" y="475488"/>
-            <a:ext cx="8229600" cy="621792"/>
+          <p:cNvPr id="2" name="chip-→"/>
+          <p:cNvSpPr/>
+          <p:nvPr/>
+        </p:nvSpPr>
+        <p:spPr>
+          <a:xfrm>
+            <a:off x="502920" y="493776"/>
+            <a:ext cx="475488" cy="475488"/>
+          </a:xfrm>
+          <a:prstGeom prst="roundRect">
+            <a:avLst>
+              <a:gd name="adj" fmla="val 19231"/>
+            </a:avLst>
+          </a:prstGeom>
+          <a:solidFill>
+            <a:srgbClr val="A64708"/>
+          </a:solidFill>
+          <a:ln w="12700">
+            <a:solidFill>
+              <a:srgbClr val="A64708"/>
+            </a:solidFill>
+            <a:prstDash val="solid"/>
+          </a:ln>
+        </p:spPr>
+      </p:sp>
+      <p:sp>
+        <p:nvSpPr>
+          <p:cNvPr id="3" name="Text 1"/>
+          <p:cNvSpPr txBox="1"/>
+          <p:nvPr/>
+        </p:nvSpPr>
+        <p:spPr>
+          <a:xfrm>
+            <a:off x="502920" y="493776"/>
+            <a:ext cx="475488" cy="475488"/>
           </a:xfrm>
           <a:prstGeom prst="rect">
             <a:avLst/>
@@ -3125,13 +3152,49 @@
           <a:bodyPr wrap="square" lIns="0" tIns="0" rIns="0" bIns="0" rtlCol="0" anchor="ctr"/>
           <a:lstStyle/>
           <a:p>
-            <a:pPr indent="0" marL="0">
-              <a:buNone/>
-            </a:pPr>
-            <a:r>
-              <a:rPr lang="en-US" sz="3400" b="1" dirty="0">
+            <a:pPr algn="ctr" indent="0" marL="0">
+              <a:buNone/>
+            </a:pPr>
+            <a:r>
+              <a:rPr lang="en-US" sz="1800" b="1" dirty="0">
                 <a:solidFill>
                   <a:srgbClr val="FFFFFF"/>
+                </a:solidFill>
+              </a:rPr>
+              <a:t>→</a:t>
+            </a:r>
+            <a:endParaRPr lang="en-US" sz="1800" dirty="0"/>
+          </a:p>
+        </p:txBody>
+      </p:sp>
+      <p:sp>
+        <p:nvSpPr>
+          <p:cNvPr id="4" name="Text 2"/>
+          <p:cNvSpPr txBox="1"/>
+          <p:nvPr/>
+        </p:nvSpPr>
+        <p:spPr>
+          <a:xfrm>
+            <a:off x="1161288" y="457200"/>
+            <a:ext cx="10497312" cy="548640"/>
+          </a:xfrm>
+          <a:prstGeom prst="rect">
+            <a:avLst/>
+          </a:prstGeom>
+          <a:noFill/>
+          <a:ln/>
+        </p:spPr>
+        <p:txBody>
+          <a:bodyPr wrap="square" lIns="0" tIns="0" rIns="0" bIns="0" rtlCol="0" anchor="ctr"/>
+          <a:lstStyle/>
+          <a:p>
+            <a:pPr indent="0" marL="0">
+              <a:buNone/>
+            </a:pPr>
+            <a:r>
+              <a:rPr lang="en-US" sz="3200" b="1" dirty="0">
+                <a:solidFill>
+                  <a:schemeClr val="tx1"/>
                 </a:solidFill>
                 <a:latin typeface="Cambria" pitchFamily="34" charset="0"/>
                 <a:ea typeface="Cambria" pitchFamily="34" charset="-122"/>
@@ -3139,20 +3202,20 @@
               </a:rPr>
               <a:t>Where this could go</a:t>
             </a:r>
-            <a:endParaRPr lang="en-US" sz="3400" dirty="0"/>
-          </a:p>
-        </p:txBody>
-      </p:sp>
-      <p:sp>
-        <p:nvSpPr>
-          <p:cNvPr id="3" name="Text 1"/>
-          <p:cNvSpPr txBox="1"/>
-          <p:nvPr/>
-        </p:nvSpPr>
-        <p:spPr>
-          <a:xfrm>
-            <a:off x="502920" y="1097280"/>
-            <a:ext cx="8229600" cy="310896"/>
+            <a:endParaRPr lang="en-US" sz="3200" dirty="0"/>
+          </a:p>
+        </p:txBody>
+      </p:sp>
+      <p:sp>
+        <p:nvSpPr>
+          <p:cNvPr id="5" name="Text 3"/>
+          <p:cNvSpPr txBox="1"/>
+          <p:nvPr/>
+        </p:nvSpPr>
+        <p:spPr>
+          <a:xfrm>
+            <a:off x="502920" y="1133856"/>
+            <a:ext cx="11155680" cy="384048"/>
           </a:xfrm>
           <a:prstGeom prst="rect">
             <a:avLst/>
@@ -3168,39 +3231,39 @@
               <a:buNone/>
             </a:pPr>
             <a:r>
-              <a:rPr lang="en-US" sz="1400" i="1" dirty="0">
+              <a:rPr lang="en-US" sz="1450" i="1" dirty="0">
                 <a:solidFill>
                   <a:srgbClr val="A64708"/>
                 </a:solidFill>
               </a:rPr>
               <a:t>Everything below is already built, measured and public.</a:t>
             </a:r>
-            <a:endParaRPr lang="en-US" sz="1400" dirty="0"/>
-          </a:p>
-        </p:txBody>
-      </p:sp>
-      <p:sp>
-        <p:nvSpPr>
-          <p:cNvPr id="4" name="close-0"/>
+            <a:endParaRPr lang="en-US" sz="1450" dirty="0"/>
+          </a:p>
+        </p:txBody>
+      </p:sp>
+      <p:sp>
+        <p:nvSpPr>
+          <p:cNvPr id="6" name="close-0"/>
           <p:cNvSpPr/>
           <p:nvPr/>
         </p:nvSpPr>
         <p:spPr>
           <a:xfrm>
-            <a:off x="502920" y="1627632"/>
-            <a:ext cx="3520440" cy="1993392"/>
+            <a:off x="502920" y="1682496"/>
+            <a:ext cx="3520440" cy="2267712"/>
           </a:xfrm>
           <a:prstGeom prst="roundRect">
             <a:avLst>
-              <a:gd name="adj" fmla="val 1835"/>
+              <a:gd name="adj" fmla="val 1613"/>
             </a:avLst>
           </a:prstGeom>
           <a:solidFill>
-            <a:srgbClr val="20242A"/>
+            <a:srgbClr val="E9EAE5"/>
           </a:solidFill>
           <a:ln w="12700">
             <a:solidFill>
-              <a:srgbClr val="20242A"/>
+              <a:srgbClr val="E9EAE5"/>
             </a:solidFill>
             <a:prstDash val="solid"/>
           </a:ln>
@@ -3208,14 +3271,14 @@
       </p:sp>
       <p:sp>
         <p:nvSpPr>
-          <p:cNvPr id="5" name="Text 3"/>
-          <p:cNvSpPr txBox="1"/>
-          <p:nvPr/>
-        </p:nvSpPr>
-        <p:spPr>
-          <a:xfrm>
-            <a:off x="740664" y="1792224"/>
-            <a:ext cx="3044952" cy="457200"/>
+          <p:cNvPr id="7" name="Text 5"/>
+          <p:cNvSpPr txBox="1"/>
+          <p:nvPr/>
+        </p:nvSpPr>
+        <p:spPr>
+          <a:xfrm>
+            <a:off x="740664" y="1847088"/>
+            <a:ext cx="3044952" cy="237744"/>
           </a:xfrm>
           <a:prstGeom prst="rect">
             <a:avLst/>
@@ -3244,14 +3307,14 @@
       </p:sp>
       <p:sp>
         <p:nvSpPr>
-          <p:cNvPr id="6" name="Text 4"/>
-          <p:cNvSpPr txBox="1"/>
-          <p:nvPr/>
-        </p:nvSpPr>
-        <p:spPr>
-          <a:xfrm>
-            <a:off x="740664" y="2286000"/>
-            <a:ext cx="3044952" cy="1261872"/>
+          <p:cNvPr id="8" name="Text 6"/>
+          <p:cNvSpPr txBox="1"/>
+          <p:nvPr/>
+        </p:nvSpPr>
+        <p:spPr>
+          <a:xfrm>
+            <a:off x="740664" y="2157984"/>
+            <a:ext cx="3044952" cy="1609344"/>
           </a:xfrm>
           <a:prstGeom prst="rect">
             <a:avLst/>
@@ -3265,61 +3328,61 @@
           <a:p>
             <a:pPr indent="0" marL="0">
               <a:spcAft>
-                <a:spcPts val="700"/>
+                <a:spcPts val="500"/>
               </a:spcAft>
               <a:buNone/>
             </a:pPr>
             <a:r>
-              <a:rPr lang="en-US" sz="1200" dirty="0">
-                <a:solidFill>
-                  <a:srgbClr val="D8DAD4"/>
-                </a:solidFill>
-              </a:rPr>
-              <a:t>The whole atlas is one SQLite file, 195 MB, that opens in any tool you already have.</a:t>
-            </a:r>
-            <a:endParaRPr lang="en-US" sz="1200" dirty="0"/>
+              <a:rPr lang="en-US" sz="1250" dirty="0">
+                <a:solidFill>
+                  <a:schemeClr val="tx1"/>
+                </a:solidFill>
+              </a:rPr>
+              <a:t>The whole atlas is one SQLite file that opens in any tool you already have.</a:t>
+            </a:r>
+            <a:endParaRPr lang="en-US" sz="1250" dirty="0"/>
           </a:p>
           <a:p>
             <a:pPr indent="0" marL="0">
               <a:spcAft>
-                <a:spcPts val="700"/>
+                <a:spcPts val="500"/>
               </a:spcAft>
               <a:buNone/>
             </a:pPr>
             <a:r>
-              <a:rPr lang="en-US" sz="1200" dirty="0">
-                <a:solidFill>
-                  <a:srgbClr val="D8DAD4"/>
-                </a:solidFill>
-              </a:rPr>
-              <a:t>A live interface at binman.mdeller.com, the code on GitHub, the adapter on Hugging Face.</a:t>
-            </a:r>
-            <a:endParaRPr lang="en-US" sz="1200" dirty="0"/>
-          </a:p>
-        </p:txBody>
-      </p:sp>
-      <p:sp>
-        <p:nvSpPr>
-          <p:cNvPr id="7" name="close-1"/>
+              <a:rPr lang="en-US" sz="1250" dirty="0">
+                <a:solidFill>
+                  <a:schemeClr val="tx1"/>
+                </a:solidFill>
+              </a:rPr>
+              <a:t>A live interface at binman.mdeller.com, the code on GitHub, the trained adapter on Hugging Face.</a:t>
+            </a:r>
+            <a:endParaRPr lang="en-US" sz="1250" dirty="0"/>
+          </a:p>
+        </p:txBody>
+      </p:sp>
+      <p:sp>
+        <p:nvSpPr>
+          <p:cNvPr id="9" name="close-1"/>
           <p:cNvSpPr/>
           <p:nvPr/>
         </p:nvSpPr>
         <p:spPr>
           <a:xfrm>
-            <a:off x="4297680" y="1627632"/>
-            <a:ext cx="3520440" cy="1993392"/>
+            <a:off x="4297680" y="1682496"/>
+            <a:ext cx="3520440" cy="2267712"/>
           </a:xfrm>
           <a:prstGeom prst="roundRect">
             <a:avLst>
-              <a:gd name="adj" fmla="val 1835"/>
+              <a:gd name="adj" fmla="val 1613"/>
             </a:avLst>
           </a:prstGeom>
           <a:solidFill>
-            <a:srgbClr val="20242A"/>
+            <a:srgbClr val="E9EAE5"/>
           </a:solidFill>
           <a:ln w="12700">
             <a:solidFill>
-              <a:srgbClr val="20242A"/>
+              <a:srgbClr val="E9EAE5"/>
             </a:solidFill>
             <a:prstDash val="solid"/>
           </a:ln>
@@ -3327,14 +3390,14 @@
       </p:sp>
       <p:sp>
         <p:nvSpPr>
-          <p:cNvPr id="8" name="Text 6"/>
-          <p:cNvSpPr txBox="1"/>
-          <p:nvPr/>
-        </p:nvSpPr>
-        <p:spPr>
-          <a:xfrm>
-            <a:off x="4535424" y="1792224"/>
-            <a:ext cx="3044952" cy="457200"/>
+          <p:cNvPr id="10" name="Text 8"/>
+          <p:cNvSpPr txBox="1"/>
+          <p:nvPr/>
+        </p:nvSpPr>
+        <p:spPr>
+          <a:xfrm>
+            <a:off x="4535424" y="1847088"/>
+            <a:ext cx="3044952" cy="237744"/>
           </a:xfrm>
           <a:prstGeom prst="rect">
             <a:avLst/>
@@ -3363,14 +3426,14 @@
       </p:sp>
       <p:sp>
         <p:nvSpPr>
-          <p:cNvPr id="9" name="Text 7"/>
-          <p:cNvSpPr txBox="1"/>
-          <p:nvPr/>
-        </p:nvSpPr>
-        <p:spPr>
-          <a:xfrm>
-            <a:off x="4535424" y="2286000"/>
-            <a:ext cx="3044952" cy="1261872"/>
+          <p:cNvPr id="11" name="Text 9"/>
+          <p:cNvSpPr txBox="1"/>
+          <p:nvPr/>
+        </p:nvSpPr>
+        <p:spPr>
+          <a:xfrm>
+            <a:off x="4535424" y="2157984"/>
+            <a:ext cx="3044952" cy="1609344"/>
           </a:xfrm>
           <a:prstGeom prst="rect">
             <a:avLst/>
@@ -3384,78 +3447,129 @@
           <a:p>
             <a:pPr indent="0" marL="0">
               <a:spcAft>
-                <a:spcPts val="700"/>
+                <a:spcPts val="500"/>
               </a:spcAft>
               <a:buNone/>
             </a:pPr>
             <a:r>
-              <a:rPr lang="en-US" sz="1200" dirty="0">
-                <a:solidFill>
-                  <a:srgbClr val="D8DAD4"/>
-                </a:solidFill>
-              </a:rPr>
-              <a:t>README — what it is and what it found.</a:t>
-            </a:r>
-            <a:endParaRPr lang="en-US" sz="1200" dirty="0"/>
+              <a:rPr lang="en-US" sz="1250" b="1" dirty="0">
+                <a:solidFill>
+                  <a:schemeClr val="tx1"/>
+                </a:solidFill>
+              </a:rPr>
+              <a:t>README</a:t>
+            </a:r>
+            <a:endParaRPr lang="en-US" sz="1250" dirty="0"/>
           </a:p>
           <a:p>
             <a:pPr indent="0" marL="0">
               <a:spcAft>
-                <a:spcPts val="700"/>
+                <a:spcPts val="500"/>
               </a:spcAft>
               <a:buNone/>
             </a:pPr>
             <a:r>
-              <a:rPr lang="en-US" sz="1200" dirty="0">
-                <a:solidFill>
-                  <a:srgbClr val="D8DAD4"/>
-                </a:solidFill>
-              </a:rPr>
-              <a:t>FINDINGS.md — every number with its method and its n, including the ones that miss.</a:t>
-            </a:r>
-            <a:endParaRPr lang="en-US" sz="1200" dirty="0"/>
+              <a:rPr lang="en-US" sz="1250" dirty="0">
+                <a:solidFill>
+                  <a:schemeClr val="tx1"/>
+                </a:solidFill>
+              </a:rPr>
+              <a:t>what it is and what it found.</a:t>
+            </a:r>
+            <a:endParaRPr lang="en-US" sz="1250" dirty="0"/>
           </a:p>
           <a:p>
             <a:pPr indent="0" marL="0">
               <a:spcAft>
-                <a:spcPts val="700"/>
+                <a:spcPts val="500"/>
               </a:spcAft>
               <a:buNone/>
             </a:pPr>
             <a:r>
-              <a:rPr lang="en-US" sz="1200" dirty="0">
-                <a:solidFill>
-                  <a:srgbClr val="D8DAD4"/>
-                </a:solidFill>
-              </a:rPr>
-              <a:t>DECISIONS.md — 92 entries, each with how to reverse it.</a:t>
-            </a:r>
-            <a:endParaRPr lang="en-US" sz="1200" dirty="0"/>
-          </a:p>
-        </p:txBody>
-      </p:sp>
-      <p:sp>
-        <p:nvSpPr>
-          <p:cNvPr id="10" name="close-2"/>
+              <a:rPr lang="en-US" sz="1250" b="1" dirty="0">
+                <a:solidFill>
+                  <a:schemeClr val="tx1"/>
+                </a:solidFill>
+              </a:rPr>
+              <a:t>FINDINGS.md</a:t>
+            </a:r>
+            <a:endParaRPr lang="en-US" sz="1250" dirty="0"/>
+          </a:p>
+          <a:p>
+            <a:pPr indent="0" marL="0">
+              <a:spcAft>
+                <a:spcPts val="500"/>
+              </a:spcAft>
+              <a:buNone/>
+            </a:pPr>
+            <a:r>
+              <a:rPr lang="en-US" sz="1250" dirty="0">
+                <a:solidFill>
+                  <a:schemeClr val="tx1"/>
+                </a:solidFill>
+              </a:rPr>
+              <a:t>every number with its method and its n, misses included.</a:t>
+            </a:r>
+            <a:endParaRPr lang="en-US" sz="1250" dirty="0"/>
+          </a:p>
+          <a:p>
+            <a:pPr indent="0" marL="0">
+              <a:spcAft>
+                <a:spcPts val="500"/>
+              </a:spcAft>
+              <a:buNone/>
+            </a:pPr>
+            <a:r>
+              <a:rPr lang="en-US" sz="1250" b="1" dirty="0">
+                <a:solidFill>
+                  <a:schemeClr val="tx1"/>
+                </a:solidFill>
+              </a:rPr>
+              <a:t>DECISIONS.md</a:t>
+            </a:r>
+            <a:endParaRPr lang="en-US" sz="1250" dirty="0"/>
+          </a:p>
+          <a:p>
+            <a:pPr indent="0" marL="0">
+              <a:spcAft>
+                <a:spcPts val="500"/>
+              </a:spcAft>
+              <a:buNone/>
+            </a:pPr>
+            <a:r>
+              <a:rPr lang="en-US" sz="1250" dirty="0">
+                <a:solidFill>
+                  <a:schemeClr val="tx1"/>
+                </a:solidFill>
+              </a:rPr>
+              <a:t>92 entries, each with how to reverse it.</a:t>
+            </a:r>
+            <a:endParaRPr lang="en-US" sz="1250" dirty="0"/>
+          </a:p>
+        </p:txBody>
+      </p:sp>
+      <p:sp>
+        <p:nvSpPr>
+          <p:cNvPr id="12" name="close-2"/>
           <p:cNvSpPr/>
           <p:nvPr/>
         </p:nvSpPr>
         <p:spPr>
           <a:xfrm>
-            <a:off x="8092440" y="1627632"/>
-            <a:ext cx="3520440" cy="1993392"/>
+            <a:off x="8092440" y="1682496"/>
+            <a:ext cx="3520440" cy="2267712"/>
           </a:xfrm>
           <a:prstGeom prst="roundRect">
             <a:avLst>
-              <a:gd name="adj" fmla="val 1835"/>
+              <a:gd name="adj" fmla="val 1613"/>
             </a:avLst>
           </a:prstGeom>
           <a:solidFill>
-            <a:srgbClr val="20242A"/>
+            <a:srgbClr val="E9EAE5"/>
           </a:solidFill>
           <a:ln w="12700">
             <a:solidFill>
-              <a:srgbClr val="20242A"/>
+              <a:srgbClr val="E9EAE5"/>
             </a:solidFill>
             <a:prstDash val="solid"/>
           </a:ln>
@@ -3463,14 +3577,14 @@
       </p:sp>
       <p:sp>
         <p:nvSpPr>
-          <p:cNvPr id="11" name="Text 9"/>
-          <p:cNvSpPr txBox="1"/>
-          <p:nvPr/>
-        </p:nvSpPr>
-        <p:spPr>
-          <a:xfrm>
-            <a:off x="8330184" y="1792224"/>
-            <a:ext cx="3044952" cy="457200"/>
+          <p:cNvPr id="13" name="Text 11"/>
+          <p:cNvSpPr txBox="1"/>
+          <p:nvPr/>
+        </p:nvSpPr>
+        <p:spPr>
+          <a:xfrm>
+            <a:off x="8330184" y="1847088"/>
+            <a:ext cx="3044952" cy="237744"/>
           </a:xfrm>
           <a:prstGeom prst="rect">
             <a:avLst/>
@@ -3499,14 +3613,14 @@
       </p:sp>
       <p:sp>
         <p:nvSpPr>
-          <p:cNvPr id="12" name="Text 10"/>
-          <p:cNvSpPr txBox="1"/>
-          <p:nvPr/>
-        </p:nvSpPr>
-        <p:spPr>
-          <a:xfrm>
-            <a:off x="8330184" y="2286000"/>
-            <a:ext cx="3044952" cy="1261872"/>
+          <p:cNvPr id="14" name="Text 12"/>
+          <p:cNvSpPr txBox="1"/>
+          <p:nvPr/>
+        </p:nvSpPr>
+        <p:spPr>
+          <a:xfrm>
+            <a:off x="8330184" y="2157984"/>
+            <a:ext cx="3044952" cy="1609344"/>
           </a:xfrm>
           <a:prstGeom prst="rect">
             <a:avLst/>
@@ -3520,66 +3634,93 @@
           <a:p>
             <a:pPr indent="0" marL="0">
               <a:spcAft>
-                <a:spcPts val="700"/>
+                <a:spcPts val="500"/>
               </a:spcAft>
               <a:buNone/>
             </a:pPr>
             <a:r>
-              <a:rPr lang="en-US" sz="1200" dirty="0">
-                <a:solidFill>
-                  <a:srgbClr val="D8DAD4"/>
+              <a:rPr lang="en-US" sz="1250" dirty="0">
+                <a:solidFill>
+                  <a:schemeClr val="tx1"/>
                 </a:solidFill>
               </a:rPr>
               <a:t>Pick a series from the 82 and put it in front of a crystallographer.</a:t>
             </a:r>
-            <a:endParaRPr lang="en-US" sz="1200" dirty="0"/>
+            <a:endParaRPr lang="en-US" sz="1250" dirty="0"/>
           </a:p>
           <a:p>
             <a:pPr indent="0" marL="0">
               <a:spcAft>
-                <a:spcPts val="700"/>
+                <a:spcPts val="500"/>
               </a:spcAft>
               <a:buNone/>
             </a:pPr>
             <a:r>
-              <a:rPr lang="en-US" sz="1200" dirty="0">
-                <a:solidFill>
-                  <a:srgbClr val="D8DAD4"/>
+              <a:rPr lang="en-US" sz="1250" dirty="0">
+                <a:solidFill>
+                  <a:schemeClr val="tx1"/>
                 </a:solidFill>
               </a:rPr>
               <a:t>Pair ligases to targets, which the ranking deliberately does not do.</a:t>
             </a:r>
-            <a:endParaRPr lang="en-US" sz="1200" dirty="0"/>
+            <a:endParaRPr lang="en-US" sz="1250" dirty="0"/>
           </a:p>
           <a:p>
             <a:pPr indent="0" marL="0">
               <a:spcAft>
-                <a:spcPts val="700"/>
+                <a:spcPts val="500"/>
               </a:spcAft>
               <a:buNone/>
             </a:pPr>
             <a:r>
-              <a:rPr lang="en-US" sz="1200" dirty="0">
-                <a:solidFill>
-                  <a:srgbClr val="D8DAD4"/>
+              <a:rPr lang="en-US" sz="1250" dirty="0">
+                <a:solidFill>
+                  <a:schemeClr val="tx1"/>
                 </a:solidFill>
               </a:rPr>
               <a:t>Superpose glue-free structures to settle induced versus pre-existing properly.</a:t>
             </a:r>
-            <a:endParaRPr lang="en-US" sz="1200" dirty="0"/>
-          </a:p>
-        </p:txBody>
-      </p:sp>
-      <p:sp>
-        <p:nvSpPr>
-          <p:cNvPr id="13" name="Text 11"/>
-          <p:cNvSpPr txBox="1"/>
-          <p:nvPr/>
-        </p:nvSpPr>
-        <p:spPr>
-          <a:xfrm>
-            <a:off x="502920" y="3950208"/>
-            <a:ext cx="10058400" cy="292608"/>
+            <a:endParaRPr lang="en-US" sz="1250" dirty="0"/>
+          </a:p>
+        </p:txBody>
+      </p:sp>
+      <p:sp>
+        <p:nvSpPr>
+          <p:cNvPr id="15" name="card"/>
+          <p:cNvSpPr/>
+          <p:nvPr/>
+        </p:nvSpPr>
+        <p:spPr>
+          <a:xfrm>
+            <a:off x="502920" y="4187952"/>
+            <a:ext cx="11155680" cy="1298448"/>
+          </a:xfrm>
+          <a:prstGeom prst="roundRect">
+            <a:avLst>
+              <a:gd name="adj" fmla="val 2817"/>
+            </a:avLst>
+          </a:prstGeom>
+          <a:solidFill>
+            <a:srgbClr val="E9EAE5"/>
+          </a:solidFill>
+          <a:ln w="12700">
+            <a:solidFill>
+              <a:srgbClr val="E9EAE5"/>
+            </a:solidFill>
+            <a:prstDash val="solid"/>
+          </a:ln>
+        </p:spPr>
+      </p:sp>
+      <p:sp>
+        <p:nvSpPr>
+          <p:cNvPr id="16" name="Text 14"/>
+          <p:cNvSpPr txBox="1"/>
+          <p:nvPr/>
+        </p:nvSpPr>
+        <p:spPr>
+          <a:xfrm>
+            <a:off x="740664" y="4352544"/>
+            <a:ext cx="10680192" cy="237744"/>
           </a:xfrm>
           <a:prstGeom prst="rect">
             <a:avLst/>
@@ -3600,7 +3741,7 @@
                   <a:srgbClr val="A64708"/>
                 </a:solidFill>
               </a:rPr>
-              <a:t>The two rules the whole project is built on</a:t>
+              <a:t>THE TWO RULES THE WHOLE PROJECT IS BUILT ON</a:t>
             </a:r>
             <a:endParaRPr lang="en-US" sz="1100" dirty="0"/>
           </a:p>
@@ -3608,14 +3749,70 @@
       </p:sp>
       <p:sp>
         <p:nvSpPr>
-          <p:cNvPr id="14" name="Text 12"/>
-          <p:cNvSpPr txBox="1"/>
-          <p:nvPr/>
-        </p:nvSpPr>
-        <p:spPr>
-          <a:xfrm>
-            <a:off x="502920" y="4297680"/>
-            <a:ext cx="11155680" cy="1078992"/>
+          <p:cNvPr id="17" name="Text 15"/>
+          <p:cNvSpPr txBox="1"/>
+          <p:nvPr/>
+        </p:nvSpPr>
+        <p:spPr>
+          <a:xfrm>
+            <a:off x="740664" y="4663440"/>
+            <a:ext cx="10680192" cy="640080"/>
+          </a:xfrm>
+          <a:prstGeom prst="rect">
+            <a:avLst/>
+          </a:prstGeom>
+          <a:noFill/>
+          <a:ln/>
+        </p:spPr>
+        <p:txBody>
+          <a:bodyPr wrap="square" lIns="0" tIns="0" rIns="0" bIns="0" rtlCol="0" anchor="t"/>
+          <a:lstStyle/>
+          <a:p>
+            <a:pPr indent="0" marL="0">
+              <a:spcAft>
+                <a:spcPts val="500"/>
+              </a:spcAft>
+              <a:buNone/>
+            </a:pPr>
+            <a:r>
+              <a:rPr lang="en-US" sz="1250" dirty="0">
+                <a:solidFill>
+                  <a:schemeClr val="tx1"/>
+                </a:solidFill>
+              </a:rPr>
+              <a:t>1 · Every module is validated against independently curated published datasets, never against controls written for this project.</a:t>
+            </a:r>
+            <a:endParaRPr lang="en-US" sz="1250" dirty="0"/>
+          </a:p>
+          <a:p>
+            <a:pPr indent="0" marL="0">
+              <a:spcAft>
+                <a:spcPts val="500"/>
+              </a:spcAft>
+              <a:buNone/>
+            </a:pPr>
+            <a:r>
+              <a:rPr lang="en-US" sz="1250" dirty="0">
+                <a:solidFill>
+                  <a:schemeClr val="tx1"/>
+                </a:solidFill>
+              </a:rPr>
+              <a:t>2 · The language model never computes, estimates or reports a number. Every figure you have seen was computed deterministically in Python.</a:t>
+            </a:r>
+            <a:endParaRPr lang="en-US" sz="1250" dirty="0"/>
+          </a:p>
+        </p:txBody>
+      </p:sp>
+      <p:sp>
+        <p:nvSpPr>
+          <p:cNvPr id="18" name="Text 16"/>
+          <p:cNvSpPr txBox="1"/>
+          <p:nvPr/>
+        </p:nvSpPr>
+        <p:spPr>
+          <a:xfrm>
+            <a:off x="502920" y="5669280"/>
+            <a:ext cx="10972800" cy="310896"/>
           </a:xfrm>
           <a:prstGeom prst="rect">
             <a:avLst/>
@@ -3628,110 +3825,62 @@
           <a:lstStyle/>
           <a:p>
             <a:pPr indent="0" marL="0">
-              <a:lnSpc>
-                <a:spcPct val="120000"/>
-              </a:lnSpc>
-              <a:buNone/>
-            </a:pPr>
-            <a:r>
-              <a:rPr lang="en-US" sz="1300" b="1" dirty="0">
-                <a:solidFill>
-                  <a:srgbClr val="E9EAE5"/>
-                </a:solidFill>
-              </a:rPr>
-              <a:t>1 · </a:t>
-            </a:r>
-            <a:pPr indent="0" marL="0">
-              <a:lnSpc>
-                <a:spcPct val="120000"/>
-              </a:lnSpc>
-              <a:buNone/>
-            </a:pPr>
-            <a:r>
-              <a:rPr lang="en-US" sz="1300" dirty="0">
-                <a:solidFill>
-                  <a:srgbClr val="E9EAE5"/>
-                </a:solidFill>
-              </a:rPr>
-              <a:t>Every module is validated against independently curated published datasets, never against controls written for this project.</a:t>
-            </a:r>
-            <a:endParaRPr lang="en-US" sz="1300" dirty="0"/>
-          </a:p>
-          <a:p>
-            <a:pPr algn="r" indent="0" marL="0">
-              <a:lnSpc>
-                <a:spcPct val="118000"/>
-              </a:lnSpc>
-              <a:buNone/>
-            </a:pPr>
-            <a:endParaRPr lang="en-US" sz="1300" dirty="0"/>
-          </a:p>
-          <a:p>
-            <a:pPr indent="0" marL="0">
-              <a:lnSpc>
-                <a:spcPct val="120000"/>
-              </a:lnSpc>
-              <a:buNone/>
-            </a:pPr>
-            <a:r>
-              <a:rPr lang="en-US" sz="1300" b="1" dirty="0">
-                <a:solidFill>
-                  <a:srgbClr val="E9EAE5"/>
-                </a:solidFill>
-              </a:rPr>
-              <a:t>2 · </a:t>
-            </a:r>
-            <a:pPr indent="0" marL="0">
-              <a:lnSpc>
-                <a:spcPct val="120000"/>
-              </a:lnSpc>
-              <a:buNone/>
-            </a:pPr>
-            <a:r>
-              <a:rPr lang="en-US" sz="1300" dirty="0">
-                <a:solidFill>
-                  <a:srgbClr val="E9EAE5"/>
-                </a:solidFill>
-              </a:rPr>
-              <a:t>The language model never computes, estimates or reports a number. Every figure you have seen was computed deterministically in Python.</a:t>
-            </a:r>
-            <a:endParaRPr lang="en-US" sz="1300" dirty="0"/>
-          </a:p>
-        </p:txBody>
-      </p:sp>
-      <p:sp>
-        <p:nvSpPr>
-          <p:cNvPr id="15" name="Text 13"/>
-          <p:cNvSpPr txBox="1"/>
-          <p:nvPr/>
-        </p:nvSpPr>
-        <p:spPr>
-          <a:xfrm>
-            <a:off x="502920" y="5852160"/>
-            <a:ext cx="10972800" cy="310896"/>
-          </a:xfrm>
-          <a:prstGeom prst="rect">
-            <a:avLst/>
-          </a:prstGeom>
-          <a:noFill/>
-          <a:ln/>
-        </p:spPr>
-        <p:txBody>
-          <a:bodyPr wrap="square" lIns="0" tIns="0" rIns="0" bIns="0" rtlCol="0" anchor="ctr"/>
-          <a:lstStyle/>
-          <a:p>
-            <a:pPr indent="0" marL="0">
               <a:buNone/>
             </a:pPr>
             <a:r>
               <a:rPr lang="en-US" sz="1150" dirty="0">
                 <a:solidFill>
-                  <a:srgbClr val="9AA096"/>
+                  <a:srgbClr val="61655F"/>
                 </a:solidFill>
               </a:rPr>
               <a:t>Marc C. Deller, D.Phil.  ·  marc@marcdeller.com  ·  binman.mdeller.com  ·  github.com/bellcheddar/BINMAN</a:t>
             </a:r>
             <a:endParaRPr lang="en-US" sz="1150" dirty="0"/>
+          </a:p>
+        </p:txBody>
+      </p:sp>
+      <p:sp>
+        <p:nvSpPr>
+          <p:cNvPr id="25" name="Slide Number Placeholder 0"/>
+          <p:cNvSpPr>
+            <a:spLocks noGrp="1"/>
+          </p:cNvSpPr>
+          <p:nvPr>
+            <p:ph type="sldNum" sz="quarter" idx="4294967295"/>
+          </p:nvPr>
+        </p:nvSpPr>
+        <p:spPr>
+          <a:xfrm>
+            <a:off x="11384280" y="6437376"/>
+            <a:ext cx="274320" cy="274320"/>
+          </a:xfrm>
+          <a:prstGeom prst="rect">
+            <a:avLst/>
+          </a:prstGeom>
+          <a:extLst>
+            <a:ext uri="{C572A759-6A51-4108-AA02-DFA0A04FC94B}">
+              <ma14:wrappingTextBoxFlag xmlns:ma14="http://schemas.microsoft.com/office/mac/drawingml/2011/main" val="0"/>
+            </a:ext>
+          </a:extLst>
+        </p:spPr>
+        <p:txBody>
+          <a:bodyPr/>
+          <a:lstStyle>
+            <a:lvl1pPr>
+              <a:defRPr sz="950">
+                <a:solidFill>
+                  <a:srgbClr val="61655F"/>
+                </a:solidFill>
+              </a:defRPr>
+            </a:lvl1pPr>
+          </a:lstStyle>
+          <a:p>
+            <a:pPr algn="r"/>
+            <a:fld id="{F7021451-1387-4CA6-816F-3879F97B5CBC}" type="slidenum">
+              <a:rPr b="0" lang="en-US"/>
+              <a:t>11</a:t>
+            </a:fld>
+            <a:endParaRPr lang="en-US"/>
           </a:p>
         </p:txBody>
       </p:sp>

</xml_diff>